<commit_message>
Complete educational exercises and traceability for all 15 labs
</commit_message>
<xml_diff>
--- a/docs/labs/lab-15/defense.pptx
+++ b/docs/labs/lab-15/defense.pptx
@@ -4227,7 +4227,7 @@
               <a:defRPr sz="2100"/>
             </a:pPr>
             <a:r>
-              <a:t>Контрактная дата и внешний UAT ещё не подтверждены.</a:t>
+              <a:t>Учебная ЛЗ9: 20 задач, выпуск 10/10; mean 31,2→33,5 ч, p85 50,925→49,3 ч. Реальная приёмка отдельно.</a:t>
             </a:r>
           </a:p>
         </p:txBody>
@@ -4480,7 +4480,7 @@
               <a:defRPr sz="2100"/>
             </a:pPr>
             <a:r>
-              <a:t>15 разделов, реестр каждого шага, воспроизводимые команды и явные незакрытые пункты.</a:t>
+              <a:t>15 учебных разборов, 275 шагов с артефактами; настоящие подтверждения и доступ — отдельный лист сдачи.</a:t>
             </a:r>
           </a:p>
         </p:txBody>

</xml_diff>